<commit_message>
Literature review and deck: add RL references and Smart-RUDP
Co-Authored-By: Claude Sonnet 5.5 <noreply@anthropic.com>
Claude-Session: https://claude.ai/code/session_01NX2zRNpdVAnzFNKmqomzKu
</commit_message>
<xml_diff>
--- a/docs/final/RUDP_Host_Guide.pptx
+++ b/docs/final/RUDP_Host_Guide.pptx
@@ -4977,7 +4977,7 @@
               <a:buChar char="•"/>
             </a:pPr>
             <a:r>
-              <a:rPr lang="en-US" sz="1600" dirty="0">
+              <a:rPr lang="en-US" sz="1400" dirty="0">
                 <a:solidFill>
                   <a:srgbClr val="1B2430"/>
                 </a:solidFill>
@@ -4987,7 +4987,7 @@
               </a:rPr>
               <a:t>Jacobson and Karels 1988 is the origin of AIMD; Chiu and Jain 1989 explains why it converges fairly.</a:t>
             </a:r>
-            <a:endParaRPr lang="en-US" sz="1600" dirty="0"/>
+            <a:endParaRPr lang="en-US" sz="1400" dirty="0"/>
           </a:p>
           <a:p>
             <a:pPr marL="342900" indent="-342900">
@@ -4998,7 +4998,7 @@
               <a:buChar char="•"/>
             </a:pPr>
             <a:r>
-              <a:rPr lang="en-US" sz="1600" dirty="0">
+              <a:rPr lang="en-US" sz="1400" dirty="0">
                 <a:solidFill>
                   <a:srgbClr val="1B2430"/>
                 </a:solidFill>
@@ -5006,9 +5006,9 @@
                 <a:ea typeface="Calibri" pitchFamily="34" charset="-122"/>
                 <a:cs typeface="Calibri" pitchFamily="34" charset="-120"/>
               </a:rPr>
-              <a:t>RFC 5681 is the standard; CUBIC is our future-work direction; QUIC and RFC 9000 are reliable transport over UDP in production.</a:t>
-            </a:r>
-            <a:endParaRPr lang="en-US" sz="1600" dirty="0"/>
+              <a:t>RFC 5681 is the standard; CUBIC is future work; QUIC and RFC 9000 are reliable transport over UDP in production.</a:t>
+            </a:r>
+            <a:endParaRPr lang="en-US" sz="1400" dirty="0"/>
           </a:p>
           <a:p>
             <a:pPr marL="342900" indent="-342900">
@@ -5019,7 +5019,7 @@
               <a:buChar char="•"/>
             </a:pPr>
             <a:r>
-              <a:rPr lang="en-US" sz="1600" dirty="0">
+              <a:rPr lang="en-US" sz="1400" dirty="0">
                 <a:solidFill>
                   <a:srgbClr val="1B2430"/>
                 </a:solidFill>
@@ -5027,9 +5027,30 @@
                 <a:ea typeface="Calibri" pitchFamily="34" charset="-122"/>
                 <a:cs typeface="Calibri" pitchFamily="34" charset="-120"/>
               </a:rPr>
+              <a:t>The AI part comes from Midhula and Arun Raj Kumar (2024) and Cao et al. (2023, DRLFcc): deep reinforcement learning for congestion control. Smart-RUDP applies the same idea with a smaller tabular Q-learning agent.</a:t>
+            </a:r>
+            <a:endParaRPr lang="en-US" sz="1400" dirty="0"/>
+          </a:p>
+          <a:p>
+            <a:pPr marL="342900" indent="-342900">
+              <a:spcAft>
+                <a:spcPts val="600"/>
+              </a:spcAft>
+              <a:buSzPct val="100000"/>
+              <a:buChar char="•"/>
+            </a:pPr>
+            <a:r>
+              <a:rPr lang="en-US" sz="1400" dirty="0">
+                <a:solidFill>
+                  <a:srgbClr val="1B2430"/>
+                </a:solidFill>
+                <a:latin typeface="Calibri" pitchFamily="34" charset="0"/>
+                <a:ea typeface="Calibri" pitchFamily="34" charset="-122"/>
+                <a:cs typeface="Calibri" pitchFamily="34" charset="-120"/>
+              </a:rPr>
               <a:t>Key researcher: Van Jacobson.</a:t>
             </a:r>
-            <a:endParaRPr lang="en-US" sz="1600" dirty="0"/>
+            <a:endParaRPr lang="en-US" sz="1400" dirty="0"/>
           </a:p>
         </p:txBody>
       </p:sp>
@@ -5105,7 +5126,7 @@
                 <a:ea typeface="Calibri" pitchFamily="34" charset="-122"/>
                 <a:cs typeface="Calibri" pitchFamily="34" charset="-120"/>
               </a:rPr>
-              <a:t>Q: Why AIMD? A: Chiu and Jain show it converges to a fair share.</a:t>
+              <a:t>Q: Why AIMD? A: Chiu and Jain show it converges to a fair share. Q: Are those papers deep RL and yours is not? A: Yes; we used a lookup table, which is simpler and inspectable.</a:t>
             </a:r>
             <a:endParaRPr lang="en-US" sz="1400" dirty="0"/>
           </a:p>

</xml_diff>

<commit_message>
Chat: window controller switch (fixed, AIMD, Smart-RUDP Q-learning), delay emulation, 60-message test; docs updated
Co-Authored-By: Claude Sonnet 5.5 <noreply@anthropic.com>
Claude-Session: https://claude.ai/code/session_01NX2zRNpdVAnzFNKmqomzKu
</commit_message>
<xml_diff>
--- a/docs/final/RUDP_Host_Guide.pptx
+++ b/docs/final/RUDP_Host_Guide.pptx
@@ -12567,7 +12567,7 @@
               <a:buChar char="•"/>
             </a:pPr>
             <a:r>
-              <a:rPr lang="en-US" sz="1600" dirty="0">
+              <a:rPr lang="en-US" sz="1400" dirty="0">
                 <a:solidFill>
                   <a:srgbClr val="1B2430"/>
                 </a:solidFill>
@@ -12577,7 +12577,7 @@
               </a:rPr>
               <a:t>The protocol in use: each message is one numbered, checksummed RUDP segment, ACKed in order.</a:t>
             </a:r>
-            <a:endParaRPr lang="en-US" sz="1600" dirty="0"/>
+            <a:endParaRPr lang="en-US" sz="1400" dirty="0"/>
           </a:p>
           <a:p>
             <a:pPr marL="342900" indent="-342900">
@@ -12588,7 +12588,7 @@
               <a:buChar char="•"/>
             </a:pPr>
             <a:r>
-              <a:rPr lang="en-US" sz="1600" dirty="0">
+              <a:rPr lang="en-US" sz="1400" dirty="0">
                 <a:solidFill>
                   <a:srgbClr val="1B2430"/>
                 </a:solidFill>
@@ -12598,7 +12598,7 @@
               </a:rPr>
               <a:t>There is a terminal version and a browser version; two devices were linked over Tailscale, laptop and phone.</a:t>
             </a:r>
-            <a:endParaRPr lang="en-US" sz="1600" dirty="0"/>
+            <a:endParaRPr lang="en-US" sz="1400" dirty="0"/>
           </a:p>
           <a:p>
             <a:pPr marL="342900" indent="-342900">
@@ -12609,7 +12609,7 @@
               <a:buChar char="•"/>
             </a:pPr>
             <a:r>
-              <a:rPr lang="en-US" sz="1600" dirty="0">
+              <a:rPr lang="en-US" sz="1400" dirty="0">
                 <a:solidFill>
                   <a:srgbClr val="1B2430"/>
                 </a:solidFill>
@@ -12619,7 +12619,7 @@
               </a:rPr>
               <a:t>Drag the loss slider: lost messages are resent and still arrive in order. The right panel shows sent, lost and resent counts and the log.</a:t>
             </a:r>
-            <a:endParaRPr lang="en-US" sz="1600" dirty="0"/>
+            <a:endParaRPr lang="en-US" sz="1400" dirty="0"/>
           </a:p>
           <a:p>
             <a:pPr marL="342900" indent="-342900">
@@ -12630,7 +12630,7 @@
               <a:buChar char="•"/>
             </a:pPr>
             <a:r>
-              <a:rPr lang="en-US" sz="1600" dirty="0">
+              <a:rPr lang="en-US" sz="1400" dirty="0">
                 <a:solidFill>
                   <a:srgbClr val="1B2430"/>
                 </a:solidFill>
@@ -12638,9 +12638,9 @@
                 <a:ea typeface="Calibri" pitchFamily="34" charset="-122"/>
                 <a:cs typeface="Calibri" pitchFamily="34" charset="-120"/>
               </a:rPr>
-              <a:t>It uses a fixed window of 8, not the Smart-RUDP controller.</a:t>
-            </a:r>
-            <a:endParaRPr lang="en-US" sz="1600" dirty="0"/>
+              <a:t>There is a controller switch: fixed window, AIMD, or Smart-RUDP, which loads the trained table and keeps learning live. A 60-message test button times delivery. Honest result: Smart-RUDP did not beat the simple rules here either.</a:t>
+            </a:r>
+            <a:endParaRPr lang="en-US" sz="1400" dirty="0"/>
           </a:p>
         </p:txBody>
       </p:sp>

</xml_diff>

<commit_message>
Smart-RUDP for chat: shared controller module, simulator, offline training (q_chat.txt), held-out evaluation; docs updated
Co-Authored-By: Claude Sonnet 5.5 <noreply@anthropic.com>
Claude-Session: https://claude.ai/code/session_01NX2zRNpdVAnzFNKmqomzKu
</commit_message>
<xml_diff>
--- a/docs/final/RUDP_Host_Guide.pptx
+++ b/docs/final/RUDP_Host_Guide.pptx
@@ -6488,7 +6488,7 @@
               <a:buChar char="•"/>
             </a:pPr>
             <a:r>
-              <a:rPr lang="en-US" sz="1600" dirty="0">
+              <a:rPr lang="en-US" sz="1400" dirty="0">
                 <a:solidFill>
                   <a:srgbClr val="1B2430"/>
                 </a:solidFill>
@@ -6498,7 +6498,7 @@
               </a:rPr>
               <a:t>Be honest: it did not beat AIMD. Plus 63 percent time on 5G-like, plus 10 percent on satellite, a tie on the lossy path.</a:t>
             </a:r>
-            <a:endParaRPr lang="en-US" sz="1600" dirty="0"/>
+            <a:endParaRPr lang="en-US" sz="1400" dirty="0"/>
           </a:p>
           <a:p>
             <a:pPr marL="342900" indent="-342900">
@@ -6509,7 +6509,7 @@
               <a:buChar char="•"/>
             </a:pPr>
             <a:r>
-              <a:rPr lang="en-US" sz="1600" dirty="0">
+              <a:rPr lang="en-US" sz="1400" dirty="0">
                 <a:solidFill>
                   <a:srgbClr val="1B2430"/>
                 </a:solidFill>
@@ -6519,7 +6519,7 @@
               </a:rPr>
               <a:t>It used somewhat fewer retransmissions on two paths, within run-to-run noise.</a:t>
             </a:r>
-            <a:endParaRPr lang="en-US" sz="1600" dirty="0"/>
+            <a:endParaRPr lang="en-US" sz="1400" dirty="0"/>
           </a:p>
           <a:p>
             <a:pPr marL="342900" indent="-342900">
@@ -6530,7 +6530,7 @@
               <a:buChar char="•"/>
             </a:pPr>
             <a:r>
-              <a:rPr lang="en-US" sz="1600" dirty="0">
+              <a:rPr lang="en-US" sz="1400" dirty="0">
                 <a:solidFill>
                   <a:srgbClr val="1B2430"/>
                 </a:solidFill>
@@ -6540,7 +6540,28 @@
               </a:rPr>
               <a:t>Earlier training rounds were much worse; this is the final configuration. The finding is that a simple learner does not beat a tuned rule.</a:t>
             </a:r>
-            <a:endParaRPr lang="en-US" sz="1600" dirty="0"/>
+            <a:endParaRPr lang="en-US" sz="1400" dirty="0"/>
+          </a:p>
+          <a:p>
+            <a:pPr marL="342900" indent="-342900">
+              <a:spcAft>
+                <a:spcPts val="600"/>
+              </a:spcAft>
+              <a:buSzPct val="100000"/>
+              <a:buChar char="•"/>
+            </a:pPr>
+            <a:r>
+              <a:rPr lang="en-US" sz="1400" dirty="0">
+                <a:solidFill>
+                  <a:srgbClr val="1B2430"/>
+                </a:solidFill>
+                <a:latin typeface="Calibri" pitchFamily="34" charset="0"/>
+                <a:ea typeface="Calibri" pitchFamily="34" charset="-122"/>
+                <a:cs typeface="Calibri" pitchFamily="34" charset="-120"/>
+              </a:rPr>
+              <a:t>In the chat, retrained for bursty random-loss traffic, it does beat AIMD on most simulated paths; mention that on slide 19.</a:t>
+            </a:r>
+            <a:endParaRPr lang="en-US" sz="1400" dirty="0"/>
           </a:p>
         </p:txBody>
       </p:sp>
@@ -12638,7 +12659,7 @@
                 <a:ea typeface="Calibri" pitchFamily="34" charset="-122"/>
                 <a:cs typeface="Calibri" pitchFamily="34" charset="-120"/>
               </a:rPr>
-              <a:t>There is a controller switch: fixed window, AIMD, or Smart-RUDP, which loads the trained table and keeps learning live. A 60-message test button times delivery. Honest result: no consistent winner; Smart-RUDP did not clearly beat the simple rules, same as the experiments.</a:t>
+              <a:t>There is a controller switch: fixed window, AIMD, or Smart-RUDP. For the chat we retrained Smart-RUDP on simulated paths: it was faster than AIMD on 5 of 6 held-out paths and equal on 1, because AIMD resets to one packet on random loss. Say it is simulated, and that the agent may not shrink the window without a congestion signal.</a:t>
             </a:r>
             <a:endParaRPr lang="en-US" sz="1400" dirty="0"/>
           </a:p>
@@ -12716,7 +12737,7 @@
                 <a:ea typeface="Calibri" pitchFamily="34" charset="-122"/>
                 <a:cs typeface="Calibri" pitchFamily="34" charset="-120"/>
               </a:rPr>
-              <a:t>Q: Is it secure? A: No encryption or accounts; it is a demo of reliability, not a product.</a:t>
+              <a:t>Q: Is that a fair win? A: Both start from the same window of 10; held-out paths and seeds; honest limits: simulated, and without the no-shrink rule the agent lost. Q: Did it win in Section 8? A: No, that result stands.</a:t>
             </a:r>
             <a:endParaRPr lang="en-US" sz="1400" dirty="0"/>
           </a:p>
@@ -14147,7 +14168,7 @@
                 <a:ea typeface="Calibri" pitchFamily="34" charset="-122"/>
                 <a:cs typeface="Calibri" pitchFamily="34" charset="-120"/>
               </a:rPr>
-              <a:t>Smart-RUDP did not win. Why include it?</a:t>
+              <a:t>Did Smart-RUDP win?</a:t>
             </a:r>
             <a:endParaRPr lang="en-US" sz="1500" dirty="0"/>
           </a:p>
@@ -14186,7 +14207,7 @@
                 <a:ea typeface="Calibri" pitchFamily="34" charset="-122"/>
                 <a:cs typeface="Calibri" pitchFamily="34" charset="-120"/>
               </a:rPr>
-              <a:t>It was the experiment: does a learned window help? We report the answer, including the negative one.</a:t>
+              <a:t>Experiments: tied on one path, slower on two, and we say so. Chat, retrained on simulated paths: faster than AIMD on 5 of 6 held-out paths, equal on 1, because AIMD resets to 1 on every timeout. Simulated; same start window 10; agent may not shrink without a congestion signal.</a:t>
             </a:r>
             <a:endParaRPr lang="en-US" sz="1350" dirty="0"/>
           </a:p>

</xml_diff>